<commit_message>
Report and slide 4: state total data (about 34 h of video, ~2,890 clips and videos)
</commit_message>
<xml_diff>
--- a/ml/artifacts/final_model_v2/cALorie_final_presentation.pptx
+++ b/ml/artifacts/final_model_v2/cALorie_final_presentation.pptx
@@ -116,44 +116,44 @@
   <p:extLst>
     <p:ext uri="{521415D9-36F7-43E2-AB2F-B90AF26B5E84}">
       <p14:sectionLst xmlns:p14="http://schemas.microsoft.com/office/powerpoint/2010/main">
-        <p14:section name="Intro" id="{2cefb022-f034-2bec-1cbc-701104fc5333}">
+        <p14:section name="Intro" id="{7935c5aa-b783-7abe-2572-f0f760f86f81}">
           <p14:sldIdLst>
             <p14:sldId id="256"/>
           </p14:sldIdLst>
         </p14:section>
-        <p14:section name="Method" id="{2eb788fa-a50b-194d-7352-a7145ef23642}">
+        <p14:section name="Method" id="{a06d0e74-37fd-4fda-4023-b70cfe1ccbad}">
           <p14:sldIdLst>
             <p14:sldId id="257"/>
           </p14:sldIdLst>
         </p14:section>
-        <p14:section name="Problem" id="{790115fb-73cc-e8a3-3849-2b7fb465c114}">
+        <p14:section name="Problem" id="{f5e38d3e-f482-ae54-86b4-718af5cb0c97}">
           <p14:sldIdLst>
             <p14:sldId id="258"/>
           </p14:sldIdLst>
         </p14:section>
-        <p14:section name="Data" id="{91cd9ab1-3c8a-8d23-088a-ab32fdab9887}">
+        <p14:section name="Data" id="{fb8bad24-8fd8-1590-549f-f8eeb9c1464e}">
           <p14:sldIdLst>
             <p14:sldId id="259"/>
           </p14:sldIdLst>
         </p14:section>
-        <p14:section name="Results" id="{7af3cc37-d561-6913-4f17-9a2be2308a40}">
+        <p14:section name="Results" id="{a5082e85-bf12-dba6-f243-bbb11ac1dd37}">
           <p14:sldIdLst>
             <p14:sldId id="260"/>
             <p14:sldId id="261"/>
             <p14:sldId id="262"/>
           </p14:sldIdLst>
         </p14:section>
-        <p14:section name="Method honesty" id="{cc06748a-39ac-70f4-8861-98c7ed6f3d24}">
+        <p14:section name="Method honesty" id="{8ad88ff0-5421-8a67-cfac-da9be971cbd0}">
           <p14:sldIdLst>
             <p14:sldId id="263"/>
           </p14:sldIdLst>
         </p14:section>
-        <p14:section name="Demo" id="{e176847b-d6de-f33f-d8f8-b5895ad7c193}">
+        <p14:section name="Demo" id="{f0a9eacd-092f-2053-b0e0-9ee17cf90b32}">
           <p14:sldIdLst>
             <p14:sldId id="264"/>
           </p14:sldIdLst>
         </p14:section>
-        <p14:section name="Wrap-up" id="{1fd4625e-f2dc-2a46-646e-d0b00a8fbc14}">
+        <p14:section name="Wrap-up" id="{6e4a4943-70a8-c51b-2050-91e100e260ed}">
           <p14:sldIdLst>
             <p14:sldId id="265"/>
           </p14:sldIdLst>
@@ -914,7 +914,7 @@
           <a:p>
             <a:r>
               <a:rPr lang="en-US" dirty="0"/>
-              <a:t>We collected 38 follow-along videos from creators we had not used before, screened out vlogs and montages, and labeled every second using a 23-rule annotation guide. The spot checks were 44 of 44, 95 of 95, and 71 of 71 correct. Two test sets were locked with file fingerprints before any model was scored.</a:t>
+              <a:t>In total about 34 hours of video was processed: roughly 1,800 short training clips (7.7 h), 1,040 RepCount clips (7.3 h), and 38 long workouts (18.8 h). We collected the 38 follow-along videos from creators we had not used before, screened out vlogs and montages, and labeled every second using a 23-rule annotation guide. The spot checks were 44 of 44, 95 of 95, and 71 of 71 correct. Two test sets were locked with file fingerprints before any model was scored.</a:t>
             </a:r>
             <a:endParaRPr lang="en-US" dirty="0"/>
           </a:p>
@@ -3795,7 +3795,7 @@
       </p:sp>
       <p:sp>
         <p:nvSpPr>
-          <p:cNvPr id="3" name="stat 38"/>
+          <p:cNvPr id="3" name="stat 34 h"/>
           <p:cNvSpPr txBox="1"/>
           <p:nvPr/>
         </p:nvSpPr>
@@ -3826,7 +3826,7 @@
                 <a:ea typeface="Cambria" pitchFamily="34" charset="-122"/>
                 <a:cs typeface="Cambria" pitchFamily="34" charset="-120"/>
               </a:rPr>
-              <a:t>38</a:t>
+              <a:t>34 h</a:t>
             </a:r>
             <a:endParaRPr lang="en-US" sz="5400" dirty="0"/>
           </a:p>
@@ -3834,7 +3834,7 @@
       </p:sp>
       <p:sp>
         <p:nvSpPr>
-          <p:cNvPr id="4" name="label 38"/>
+          <p:cNvPr id="4" name="label 34 h"/>
           <p:cNvSpPr txBox="1"/>
           <p:nvPr/>
         </p:nvSpPr>
@@ -3865,7 +3865,7 @@
                 <a:ea typeface="Calibri" pitchFamily="34" charset="-122"/>
                 <a:cs typeface="Calibri" pitchFamily="34" charset="-120"/>
               </a:rPr>
-              <a:t>workout videos, labeled by hand-written rules</a:t>
+              <a:t>of video turned into pose data, from about 2,900 clips and videos</a:t>
             </a:r>
             <a:endParaRPr lang="en-US" sz="1600" dirty="0"/>
           </a:p>
@@ -3943,7 +3943,7 @@
                 <a:ea typeface="Calibri" pitchFamily="34" charset="-122"/>
                 <a:cs typeface="Calibri" pitchFamily="34" charset="-120"/>
               </a:rPr>
-              <a:t>of real follow-along workouts, raw video deleted</a:t>
+              <a:t>of it real follow-along workouts: 38 videos labeled second by second</a:t>
             </a:r>
             <a:endParaRPr lang="en-US" sz="1600" dirty="0"/>
           </a:p>
@@ -4060,7 +4060,7 @@
                 <a:ea typeface="Calibri" pitchFamily="34" charset="-122"/>
                 <a:cs typeface="Calibri" pitchFamily="34" charset="-120"/>
               </a:rPr>
-              <a:t>Every second is rest, warm-up, a supported exercise, or “unknown”. Two sets of videos were locked away and never used to train or tune anything.</a:t>
+              <a:t>Every second of these 38 workouts is rest, warm-up, a supported exercise, or “unknown”. Together with about 2,850 shorter clips, that is roughly 34 hours of video turned into body-pose data. Two video sets were locked away and never used to train or tune.</a:t>
             </a:r>
             <a:endParaRPr lang="en-US" sz="1600" dirty="0"/>
           </a:p>

</xml_diff>

<commit_message>
Web page redesign (dark, long-video friendly, run script) and darker slide deck
</commit_message>
<xml_diff>
--- a/ml/artifacts/final_model_v2/cALorie_final_presentation.pptx
+++ b/ml/artifacts/final_model_v2/cALorie_final_presentation.pptx
@@ -116,44 +116,44 @@
   <p:extLst>
     <p:ext uri="{521415D9-36F7-43E2-AB2F-B90AF26B5E84}">
       <p14:sectionLst xmlns:p14="http://schemas.microsoft.com/office/powerpoint/2010/main">
-        <p14:section name="Intro" id="{7935c5aa-b783-7abe-2572-f0f760f86f81}">
+        <p14:section name="Intro" id="{69c4fd60-a4ad-7028-c0fc-2715cfdd9069}">
           <p14:sldIdLst>
             <p14:sldId id="256"/>
           </p14:sldIdLst>
         </p14:section>
-        <p14:section name="Method" id="{a06d0e74-37fd-4fda-4023-b70cfe1ccbad}">
+        <p14:section name="Method" id="{82ca21e2-424a-ea8f-87e0-797945ed6390}">
           <p14:sldIdLst>
             <p14:sldId id="257"/>
           </p14:sldIdLst>
         </p14:section>
-        <p14:section name="Problem" id="{f5e38d3e-f482-ae54-86b4-718af5cb0c97}">
+        <p14:section name="Problem" id="{432fb182-1afd-f11a-2fa1-68654f8773f9}">
           <p14:sldIdLst>
             <p14:sldId id="258"/>
           </p14:sldIdLst>
         </p14:section>
-        <p14:section name="Data" id="{fb8bad24-8fd8-1590-549f-f8eeb9c1464e}">
+        <p14:section name="Data" id="{f43f1ac2-0522-c8ee-63eb-f6a45a9d9988}">
           <p14:sldIdLst>
             <p14:sldId id="259"/>
           </p14:sldIdLst>
         </p14:section>
-        <p14:section name="Results" id="{a5082e85-bf12-dba6-f243-bbb11ac1dd37}">
+        <p14:section name="Results" id="{78716c69-d24a-cf27-c384-6c24a1fe8e59}">
           <p14:sldIdLst>
             <p14:sldId id="260"/>
             <p14:sldId id="261"/>
             <p14:sldId id="262"/>
           </p14:sldIdLst>
         </p14:section>
-        <p14:section name="Method honesty" id="{8ad88ff0-5421-8a67-cfac-da9be971cbd0}">
+        <p14:section name="Method honesty" id="{377448cf-bd28-04d1-3c6e-5b6d7a70ddf0}">
           <p14:sldIdLst>
             <p14:sldId id="263"/>
           </p14:sldIdLst>
         </p14:section>
-        <p14:section name="Demo" id="{f0a9eacd-092f-2053-b0e0-9ee17cf90b32}">
+        <p14:section name="Demo" id="{ca4b6b9f-18c2-71d3-1d31-23e36857a543}">
           <p14:sldIdLst>
             <p14:sldId id="264"/>
           </p14:sldIdLst>
         </p14:section>
-        <p14:section name="Wrap-up" id="{6e4a4943-70a8-c51b-2050-91e100e260ed}">
+        <p14:section name="Wrap-up" id="{d8bee38f-ad38-a04d-acf6-7e39065854f2}">
           <p14:sldIdLst>
             <p14:sldId id="265"/>
           </p14:sldIdLst>
@@ -1464,7 +1464,7 @@
     <p:bg>
       <p:bgPr>
         <a:solidFill>
-          <a:srgbClr val="FFFFFF"/>
+          <a:srgbClr val="12151C"/>
         </a:solidFill>
       </p:bgPr>
     </p:bg>
@@ -1508,7 +1508,7 @@
               <a:buNone/>
               <a:defRPr lang="en-US" sz="3200" b="1" dirty="0">
                 <a:solidFill>
-                  <a:schemeClr val="tx1"/>
+                  <a:schemeClr val="bg1"/>
                 </a:solidFill>
                 <a:latin typeface="Cambria" pitchFamily="34" charset="0"/>
                 <a:ea typeface="Cambria" pitchFamily="34" charset="-122"/>
@@ -1949,7 +1949,7 @@
               <a:buNone/>
             </a:pPr>
             <a:r>
-              <a:rPr lang="en-US" sz="5400" b="1" dirty="0">
+              <a:rPr lang="en-US" sz="6000" b="1" dirty="0">
                 <a:solidFill>
                   <a:schemeClr val="bg1"/>
                 </a:solidFill>
@@ -1957,9 +1957,37 @@
                 <a:ea typeface="Cambria" pitchFamily="34" charset="-122"/>
                 <a:cs typeface="Cambria" pitchFamily="34" charset="-120"/>
               </a:rPr>
-              <a:t>cALorie</a:t>
-            </a:r>
-            <a:endParaRPr lang="en-US" sz="5400" dirty="0"/>
+              <a:t>c</a:t>
+            </a:r>
+            <a:pPr indent="0" marL="0">
+              <a:buNone/>
+            </a:pPr>
+            <a:r>
+              <a:rPr lang="en-US" sz="6000" b="1" dirty="0">
+                <a:solidFill>
+                  <a:srgbClr val="FF7A45"/>
+                </a:solidFill>
+                <a:latin typeface="Cambria" pitchFamily="34" charset="0"/>
+                <a:ea typeface="Cambria" pitchFamily="34" charset="-122"/>
+                <a:cs typeface="Cambria" pitchFamily="34" charset="-120"/>
+              </a:rPr>
+              <a:t>AL</a:t>
+            </a:r>
+            <a:pPr indent="0" marL="0">
+              <a:buNone/>
+            </a:pPr>
+            <a:r>
+              <a:rPr lang="en-US" sz="6000" b="1" dirty="0">
+                <a:solidFill>
+                  <a:schemeClr val="bg1"/>
+                </a:solidFill>
+                <a:latin typeface="Cambria" pitchFamily="34" charset="0"/>
+                <a:ea typeface="Cambria" pitchFamily="34" charset="-122"/>
+                <a:cs typeface="Cambria" pitchFamily="34" charset="-120"/>
+              </a:rPr>
+              <a:t>orie</a:t>
+            </a:r>
+            <a:endParaRPr lang="en-US" sz="6000" dirty="0"/>
           </a:p>
         </p:txBody>
       </p:sp>
@@ -2056,7 +2084,7 @@
             <a:avLst/>
           </a:prstGeom>
           <a:solidFill>
-            <a:schemeClr val="accent1"/>
+            <a:srgbClr val="FF7A45"/>
           </a:solidFill>
           <a:ln/>
         </p:spPr>
@@ -2076,7 +2104,7 @@
             <a:avLst/>
           </a:prstGeom>
           <a:solidFill>
-            <a:schemeClr val="accent2"/>
+            <a:srgbClr val="8F84F0"/>
           </a:solidFill>
           <a:ln/>
         </p:spPr>
@@ -2096,7 +2124,7 @@
             <a:avLst/>
           </a:prstGeom>
           <a:solidFill>
-            <a:schemeClr val="accent3"/>
+            <a:srgbClr val="5B9BEB"/>
           </a:solidFill>
           <a:ln/>
         </p:spPr>
@@ -2116,7 +2144,7 @@
             <a:avLst/>
           </a:prstGeom>
           <a:solidFill>
-            <a:schemeClr val="accent4"/>
+            <a:srgbClr val="2FCB93"/>
           </a:solidFill>
           <a:ln/>
         </p:spPr>
@@ -2136,7 +2164,7 @@
             <a:avLst/>
           </a:prstGeom>
           <a:solidFill>
-            <a:schemeClr val="accent5"/>
+            <a:srgbClr val="F5B82E"/>
           </a:solidFill>
           <a:ln/>
         </p:spPr>
@@ -2195,7 +2223,7 @@
             <a:r>
               <a:rPr lang="en-US" sz="3200" b="1" dirty="0">
                 <a:solidFill>
-                  <a:schemeClr val="tx1"/>
+                  <a:schemeClr val="bg1"/>
                 </a:solidFill>
                 <a:latin typeface="Cambria" pitchFamily="34" charset="0"/>
                 <a:ea typeface="Cambria" pitchFamily="34" charset="-122"/>
@@ -2237,7 +2265,7 @@
             <a:r>
               <a:rPr lang="en-US" sz="2000" b="1" dirty="0">
                 <a:solidFill>
-                  <a:schemeClr val="accent1"/>
+                  <a:srgbClr val="FF7A45"/>
                 </a:solidFill>
                 <a:latin typeface="Cambria" pitchFamily="34" charset="0"/>
                 <a:ea typeface="Cambria" pitchFamily="34" charset="-122"/>
@@ -2258,7 +2286,7 @@
             <a:r>
               <a:rPr lang="en-US" sz="1500" dirty="0">
                 <a:solidFill>
-                  <a:schemeClr val="tx2"/>
+                  <a:srgbClr val="C9CEDF"/>
                 </a:solidFill>
                 <a:latin typeface="Calibri" pitchFamily="34" charset="0"/>
                 <a:ea typeface="Calibri" pitchFamily="34" charset="-122"/>
@@ -2279,7 +2307,7 @@
             <a:r>
               <a:rPr lang="en-US" sz="1500" dirty="0">
                 <a:solidFill>
-                  <a:schemeClr val="tx2"/>
+                  <a:srgbClr val="C9CEDF"/>
                 </a:solidFill>
                 <a:latin typeface="Calibri" pitchFamily="34" charset="0"/>
                 <a:ea typeface="Calibri" pitchFamily="34" charset="-122"/>
@@ -2300,7 +2328,7 @@
             <a:r>
               <a:rPr lang="en-US" sz="1500" dirty="0">
                 <a:solidFill>
-                  <a:schemeClr val="tx2"/>
+                  <a:srgbClr val="C9CEDF"/>
                 </a:solidFill>
                 <a:latin typeface="Calibri" pitchFamily="34" charset="0"/>
                 <a:ea typeface="Calibri" pitchFamily="34" charset="-122"/>
@@ -2321,7 +2349,7 @@
             <a:r>
               <a:rPr lang="en-US" sz="1500" dirty="0">
                 <a:solidFill>
-                  <a:schemeClr val="tx2"/>
+                  <a:srgbClr val="C9CEDF"/>
                 </a:solidFill>
                 <a:latin typeface="Calibri" pitchFamily="34" charset="0"/>
                 <a:ea typeface="Calibri" pitchFamily="34" charset="-122"/>
@@ -2363,7 +2391,7 @@
             <a:r>
               <a:rPr lang="en-US" sz="2000" b="1" dirty="0">
                 <a:solidFill>
-                  <a:schemeClr val="accent2"/>
+                  <a:srgbClr val="8F84F0"/>
                 </a:solidFill>
                 <a:latin typeface="Cambria" pitchFamily="34" charset="0"/>
                 <a:ea typeface="Cambria" pitchFamily="34" charset="-122"/>
@@ -2384,7 +2412,7 @@
             <a:r>
               <a:rPr lang="en-US" sz="1500" dirty="0">
                 <a:solidFill>
-                  <a:schemeClr val="tx2"/>
+                  <a:srgbClr val="C9CEDF"/>
                 </a:solidFill>
                 <a:latin typeface="Calibri" pitchFamily="34" charset="0"/>
                 <a:ea typeface="Calibri" pitchFamily="34" charset="-122"/>
@@ -2405,7 +2433,7 @@
             <a:r>
               <a:rPr lang="en-US" sz="1500" dirty="0">
                 <a:solidFill>
-                  <a:schemeClr val="tx2"/>
+                  <a:srgbClr val="C9CEDF"/>
                 </a:solidFill>
                 <a:latin typeface="Calibri" pitchFamily="34" charset="0"/>
                 <a:ea typeface="Calibri" pitchFamily="34" charset="-122"/>
@@ -2426,7 +2454,7 @@
             <a:r>
               <a:rPr lang="en-US" sz="1500" dirty="0">
                 <a:solidFill>
-                  <a:schemeClr val="tx2"/>
+                  <a:srgbClr val="C9CEDF"/>
                 </a:solidFill>
                 <a:latin typeface="Calibri" pitchFamily="34" charset="0"/>
                 <a:ea typeface="Calibri" pitchFamily="34" charset="-122"/>
@@ -2447,7 +2475,7 @@
             <a:r>
               <a:rPr lang="en-US" sz="1500" dirty="0">
                 <a:solidFill>
-                  <a:schemeClr val="tx2"/>
+                  <a:srgbClr val="C9CEDF"/>
                 </a:solidFill>
                 <a:latin typeface="Calibri" pitchFamily="34" charset="0"/>
                 <a:ea typeface="Calibri" pitchFamily="34" charset="-122"/>
@@ -2561,7 +2589,7 @@
             <a:r>
               <a:rPr lang="en-US" sz="3200" b="1" dirty="0">
                 <a:solidFill>
-                  <a:schemeClr val="tx1"/>
+                  <a:schemeClr val="bg1"/>
                 </a:solidFill>
                 <a:latin typeface="Cambria" pitchFamily="34" charset="0"/>
                 <a:ea typeface="Cambria" pitchFamily="34" charset="-122"/>
@@ -2590,7 +2618,7 @@
             </a:avLst>
           </a:prstGeom>
           <a:solidFill>
-            <a:schemeClr val="bg2"/>
+            <a:srgbClr val="1C2130"/>
           </a:solidFill>
           <a:ln/>
         </p:spPr>
@@ -2610,7 +2638,7 @@
             <a:avLst/>
           </a:prstGeom>
           <a:solidFill>
-            <a:schemeClr val="accent3"/>
+            <a:srgbClr val="5B9BEB"/>
           </a:solidFill>
           <a:ln/>
         </p:spPr>
@@ -2642,7 +2670,7 @@
             <a:r>
               <a:rPr lang="en-US" sz="1800" b="1" dirty="0">
                 <a:solidFill>
-                  <a:schemeClr val="tx1"/>
+                  <a:schemeClr val="bg1"/>
                 </a:solidFill>
                 <a:latin typeface="Cambria" pitchFamily="34" charset="0"/>
                 <a:ea typeface="Cambria" pitchFamily="34" charset="-122"/>
@@ -2681,7 +2709,7 @@
             <a:r>
               <a:rPr lang="en-US" sz="1200" dirty="0">
                 <a:solidFill>
-                  <a:schemeClr val="tx2"/>
+                  <a:srgbClr val="C9CEDF"/>
                 </a:solidFill>
                 <a:latin typeface="Calibri" pitchFamily="34" charset="0"/>
                 <a:ea typeface="Calibri" pitchFamily="34" charset="-122"/>
@@ -2730,7 +2758,7 @@
             </a:avLst>
           </a:prstGeom>
           <a:solidFill>
-            <a:schemeClr val="bg2"/>
+            <a:srgbClr val="1C2130"/>
           </a:solidFill>
           <a:ln/>
         </p:spPr>
@@ -2750,7 +2778,7 @@
             <a:avLst/>
           </a:prstGeom>
           <a:solidFill>
-            <a:schemeClr val="accent4"/>
+            <a:srgbClr val="2FCB93"/>
           </a:solidFill>
           <a:ln/>
         </p:spPr>
@@ -2782,7 +2810,7 @@
             <a:r>
               <a:rPr lang="en-US" sz="1800" b="1" dirty="0">
                 <a:solidFill>
-                  <a:schemeClr val="tx1"/>
+                  <a:schemeClr val="bg1"/>
                 </a:solidFill>
                 <a:latin typeface="Cambria" pitchFamily="34" charset="0"/>
                 <a:ea typeface="Cambria" pitchFamily="34" charset="-122"/>
@@ -2821,7 +2849,7 @@
             <a:r>
               <a:rPr lang="en-US" sz="1200" dirty="0">
                 <a:solidFill>
-                  <a:schemeClr val="tx2"/>
+                  <a:srgbClr val="C9CEDF"/>
                 </a:solidFill>
                 <a:latin typeface="Calibri" pitchFamily="34" charset="0"/>
                 <a:ea typeface="Calibri" pitchFamily="34" charset="-122"/>
@@ -2870,7 +2898,7 @@
             </a:avLst>
           </a:prstGeom>
           <a:solidFill>
-            <a:schemeClr val="bg2"/>
+            <a:srgbClr val="1C2130"/>
           </a:solidFill>
           <a:ln/>
         </p:spPr>
@@ -2890,7 +2918,7 @@
             <a:avLst/>
           </a:prstGeom>
           <a:solidFill>
-            <a:schemeClr val="accent5"/>
+            <a:srgbClr val="F5B82E"/>
           </a:solidFill>
           <a:ln/>
         </p:spPr>
@@ -2922,7 +2950,7 @@
             <a:r>
               <a:rPr lang="en-US" sz="1800" b="1" dirty="0">
                 <a:solidFill>
-                  <a:schemeClr val="tx1"/>
+                  <a:schemeClr val="bg1"/>
                 </a:solidFill>
                 <a:latin typeface="Cambria" pitchFamily="34" charset="0"/>
                 <a:ea typeface="Cambria" pitchFamily="34" charset="-122"/>
@@ -2961,7 +2989,7 @@
             <a:r>
               <a:rPr lang="en-US" sz="1200" dirty="0">
                 <a:solidFill>
-                  <a:schemeClr val="tx2"/>
+                  <a:srgbClr val="C9CEDF"/>
                 </a:solidFill>
                 <a:latin typeface="Calibri" pitchFamily="34" charset="0"/>
                 <a:ea typeface="Calibri" pitchFamily="34" charset="-122"/>
@@ -3010,7 +3038,7 @@
             </a:avLst>
           </a:prstGeom>
           <a:solidFill>
-            <a:schemeClr val="bg2"/>
+            <a:srgbClr val="1C2130"/>
           </a:solidFill>
           <a:ln/>
         </p:spPr>
@@ -3030,7 +3058,7 @@
             <a:avLst/>
           </a:prstGeom>
           <a:solidFill>
-            <a:schemeClr val="accent1"/>
+            <a:srgbClr val="FF7A45"/>
           </a:solidFill>
           <a:ln/>
         </p:spPr>
@@ -3062,7 +3090,7 @@
             <a:r>
               <a:rPr lang="en-US" sz="1800" b="1" dirty="0">
                 <a:solidFill>
-                  <a:schemeClr val="tx1"/>
+                  <a:schemeClr val="bg1"/>
                 </a:solidFill>
                 <a:latin typeface="Cambria" pitchFamily="34" charset="0"/>
                 <a:ea typeface="Cambria" pitchFamily="34" charset="-122"/>
@@ -3101,7 +3129,7 @@
             <a:r>
               <a:rPr lang="en-US" sz="1200" dirty="0">
                 <a:solidFill>
-                  <a:schemeClr val="tx2"/>
+                  <a:srgbClr val="C9CEDF"/>
                 </a:solidFill>
                 <a:latin typeface="Calibri" pitchFamily="34" charset="0"/>
                 <a:ea typeface="Calibri" pitchFamily="34" charset="-122"/>
@@ -3150,7 +3178,7 @@
             </a:avLst>
           </a:prstGeom>
           <a:solidFill>
-            <a:schemeClr val="bg2"/>
+            <a:srgbClr val="1C2130"/>
           </a:solidFill>
           <a:ln/>
         </p:spPr>
@@ -3170,7 +3198,7 @@
             <a:avLst/>
           </a:prstGeom>
           <a:solidFill>
-            <a:schemeClr val="accent2"/>
+            <a:srgbClr val="8F84F0"/>
           </a:solidFill>
           <a:ln/>
         </p:spPr>
@@ -3202,7 +3230,7 @@
             <a:r>
               <a:rPr lang="en-US" sz="1800" b="1" dirty="0">
                 <a:solidFill>
-                  <a:schemeClr val="tx1"/>
+                  <a:schemeClr val="bg1"/>
                 </a:solidFill>
                 <a:latin typeface="Cambria" pitchFamily="34" charset="0"/>
                 <a:ea typeface="Cambria" pitchFamily="34" charset="-122"/>
@@ -3241,7 +3269,7 @@
             <a:r>
               <a:rPr lang="en-US" sz="1200" dirty="0">
                 <a:solidFill>
-                  <a:schemeClr val="tx2"/>
+                  <a:srgbClr val="C9CEDF"/>
                 </a:solidFill>
                 <a:latin typeface="Calibri" pitchFamily="34" charset="0"/>
                 <a:ea typeface="Calibri" pitchFamily="34" charset="-122"/>
@@ -3280,7 +3308,7 @@
             <a:r>
               <a:rPr lang="en-US" sz="1600" dirty="0">
                 <a:solidFill>
-                  <a:schemeClr val="tx2"/>
+                  <a:srgbClr val="C9CEDF"/>
                 </a:solidFill>
                 <a:latin typeface="Calibri" pitchFamily="34" charset="0"/>
                 <a:ea typeface="Calibri" pitchFamily="34" charset="-122"/>
@@ -3394,7 +3422,7 @@
             <a:r>
               <a:rPr lang="en-US" sz="3200" b="1" dirty="0">
                 <a:solidFill>
-                  <a:schemeClr val="tx1"/>
+                  <a:schemeClr val="bg1"/>
                 </a:solidFill>
                 <a:latin typeface="Cambria" pitchFamily="34" charset="0"/>
                 <a:ea typeface="Cambria" pitchFamily="34" charset="-122"/>
@@ -3433,7 +3461,7 @@
             <a:r>
               <a:rPr lang="en-US" sz="5400" b="1" dirty="0">
                 <a:solidFill>
-                  <a:schemeClr val="accent3"/>
+                  <a:srgbClr val="5B9BEB"/>
                 </a:solidFill>
                 <a:latin typeface="Cambria" pitchFamily="34" charset="0"/>
                 <a:ea typeface="Cambria" pitchFamily="34" charset="-122"/>
@@ -3472,7 +3500,7 @@
             <a:r>
               <a:rPr lang="en-US" sz="1600" dirty="0">
                 <a:solidFill>
-                  <a:schemeClr val="tx2"/>
+                  <a:srgbClr val="C9CEDF"/>
                 </a:solidFill>
                 <a:latin typeface="Calibri" pitchFamily="34" charset="0"/>
                 <a:ea typeface="Calibri" pitchFamily="34" charset="-122"/>
@@ -3511,7 +3539,7 @@
             <a:r>
               <a:rPr lang="en-US" sz="5400" b="1" dirty="0">
                 <a:solidFill>
-                  <a:schemeClr val="accent1"/>
+                  <a:srgbClr val="FF7A45"/>
                 </a:solidFill>
                 <a:latin typeface="Cambria" pitchFamily="34" charset="0"/>
                 <a:ea typeface="Cambria" pitchFamily="34" charset="-122"/>
@@ -3550,7 +3578,7 @@
             <a:r>
               <a:rPr lang="en-US" sz="1600" dirty="0">
                 <a:solidFill>
-                  <a:schemeClr val="tx2"/>
+                  <a:srgbClr val="C9CEDF"/>
                 </a:solidFill>
                 <a:latin typeface="Calibri" pitchFamily="34" charset="0"/>
                 <a:ea typeface="Calibri" pitchFamily="34" charset="-122"/>
@@ -3589,7 +3617,7 @@
             <a:r>
               <a:rPr lang="en-US" sz="5400" b="1" dirty="0">
                 <a:solidFill>
-                  <a:schemeClr val="accent2"/>
+                  <a:srgbClr val="8F84F0"/>
                 </a:solidFill>
                 <a:latin typeface="Cambria" pitchFamily="34" charset="0"/>
                 <a:ea typeface="Cambria" pitchFamily="34" charset="-122"/>
@@ -3628,7 +3656,7 @@
             <a:r>
               <a:rPr lang="en-US" sz="1600" dirty="0">
                 <a:solidFill>
-                  <a:schemeClr val="tx2"/>
+                  <a:srgbClr val="C9CEDF"/>
                 </a:solidFill>
                 <a:latin typeface="Calibri" pitchFamily="34" charset="0"/>
                 <a:ea typeface="Calibri" pitchFamily="34" charset="-122"/>
@@ -3667,7 +3695,7 @@
             <a:r>
               <a:rPr lang="en-US" sz="1600" dirty="0">
                 <a:solidFill>
-                  <a:schemeClr val="tx2"/>
+                  <a:srgbClr val="C9CEDF"/>
                 </a:solidFill>
                 <a:latin typeface="Calibri" pitchFamily="34" charset="0"/>
                 <a:ea typeface="Calibri" pitchFamily="34" charset="-122"/>
@@ -3781,7 +3809,7 @@
             <a:r>
               <a:rPr lang="en-US" sz="3200" b="1" dirty="0">
                 <a:solidFill>
-                  <a:schemeClr val="tx1"/>
+                  <a:schemeClr val="bg1"/>
                 </a:solidFill>
                 <a:latin typeface="Cambria" pitchFamily="34" charset="0"/>
                 <a:ea typeface="Cambria" pitchFamily="34" charset="-122"/>
@@ -3820,7 +3848,7 @@
             <a:r>
               <a:rPr lang="en-US" sz="5400" b="1" dirty="0">
                 <a:solidFill>
-                  <a:schemeClr val="accent1"/>
+                  <a:srgbClr val="FF7A45"/>
                 </a:solidFill>
                 <a:latin typeface="Cambria" pitchFamily="34" charset="0"/>
                 <a:ea typeface="Cambria" pitchFamily="34" charset="-122"/>
@@ -3859,7 +3887,7 @@
             <a:r>
               <a:rPr lang="en-US" sz="1600" dirty="0">
                 <a:solidFill>
-                  <a:schemeClr val="tx2"/>
+                  <a:srgbClr val="C9CEDF"/>
                 </a:solidFill>
                 <a:latin typeface="Calibri" pitchFamily="34" charset="0"/>
                 <a:ea typeface="Calibri" pitchFamily="34" charset="-122"/>
@@ -3898,7 +3926,7 @@
             <a:r>
               <a:rPr lang="en-US" sz="5400" b="1" dirty="0">
                 <a:solidFill>
-                  <a:schemeClr val="accent2"/>
+                  <a:srgbClr val="8F84F0"/>
                 </a:solidFill>
                 <a:latin typeface="Cambria" pitchFamily="34" charset="0"/>
                 <a:ea typeface="Cambria" pitchFamily="34" charset="-122"/>
@@ -3937,7 +3965,7 @@
             <a:r>
               <a:rPr lang="en-US" sz="1600" dirty="0">
                 <a:solidFill>
-                  <a:schemeClr val="tx2"/>
+                  <a:srgbClr val="C9CEDF"/>
                 </a:solidFill>
                 <a:latin typeface="Calibri" pitchFamily="34" charset="0"/>
                 <a:ea typeface="Calibri" pitchFamily="34" charset="-122"/>
@@ -3976,7 +4004,7 @@
             <a:r>
               <a:rPr lang="en-US" sz="5400" b="1" dirty="0">
                 <a:solidFill>
-                  <a:schemeClr val="accent4"/>
+                  <a:srgbClr val="2FCB93"/>
                 </a:solidFill>
                 <a:latin typeface="Cambria" pitchFamily="34" charset="0"/>
                 <a:ea typeface="Cambria" pitchFamily="34" charset="-122"/>
@@ -4015,7 +4043,7 @@
             <a:r>
               <a:rPr lang="en-US" sz="1600" dirty="0">
                 <a:solidFill>
-                  <a:schemeClr val="tx2"/>
+                  <a:srgbClr val="C9CEDF"/>
                 </a:solidFill>
                 <a:latin typeface="Calibri" pitchFamily="34" charset="0"/>
                 <a:ea typeface="Calibri" pitchFamily="34" charset="-122"/>
@@ -4054,7 +4082,7 @@
             <a:r>
               <a:rPr lang="en-US" sz="1600" dirty="0">
                 <a:solidFill>
-                  <a:schemeClr val="tx2"/>
+                  <a:srgbClr val="C9CEDF"/>
                 </a:solidFill>
                 <a:latin typeface="Calibri" pitchFamily="34" charset="0"/>
                 <a:ea typeface="Calibri" pitchFamily="34" charset="-122"/>
@@ -4168,7 +4196,7 @@
             <a:r>
               <a:rPr lang="en-US" sz="3200" b="1" dirty="0">
                 <a:solidFill>
-                  <a:schemeClr val="tx1"/>
+                  <a:schemeClr val="bg1"/>
                 </a:solidFill>
                 <a:latin typeface="Cambria" pitchFamily="34" charset="0"/>
                 <a:ea typeface="Cambria" pitchFamily="34" charset="-122"/>
@@ -4180,9 +4208,31 @@
           </a:p>
         </p:txBody>
       </p:sp>
+      <p:sp>
+        <p:nvSpPr>
+          <p:cNvPr id="3" name="chart card"/>
+          <p:cNvSpPr/>
+          <p:nvPr/>
+        </p:nvSpPr>
+        <p:spPr>
+          <a:xfrm>
+            <a:off x="438912" y="1097280"/>
+            <a:ext cx="8266176" cy="3721608"/>
+          </a:xfrm>
+          <a:prstGeom prst="roundRect">
+            <a:avLst>
+              <a:gd name="adj" fmla="val 1966"/>
+            </a:avLst>
+          </a:prstGeom>
+          <a:solidFill>
+            <a:srgbClr val="FCFCFB"/>
+          </a:solidFill>
+          <a:ln/>
+        </p:spPr>
+      </p:sp>
       <p:pic>
         <p:nvPicPr>
-          <p:cNvPr id="3" name="chart progression" descr="Bar charts of Macro F1 on two locked test sets: 32.6, 32.3 and 47.6 percent on test 1; 38.7 and 43.5 percent on test 2">    </p:cNvPr>
+          <p:cNvPr id="4" name="chart progression" descr="Bar charts of Macro F1 on two locked test sets: 32.6, 32.3 and 47.6 percent on test 1; 38.7 and 43.5 percent on test 2">    </p:cNvPr>
           <p:cNvPicPr>
             <a:picLocks noChangeAspect="1"/>
           </p:cNvPicPr>
@@ -4306,7 +4356,7 @@
             <a:r>
               <a:rPr lang="en-US" sz="3200" b="1" dirty="0">
                 <a:solidFill>
-                  <a:schemeClr val="tx1"/>
+                  <a:schemeClr val="bg1"/>
                 </a:solidFill>
                 <a:latin typeface="Cambria" pitchFamily="34" charset="0"/>
                 <a:ea typeface="Cambria" pitchFamily="34" charset="-122"/>
@@ -4318,9 +4368,31 @@
           </a:p>
         </p:txBody>
       </p:sp>
+      <p:sp>
+        <p:nvSpPr>
+          <p:cNvPr id="3" name="chart card"/>
+          <p:cNvSpPr/>
+          <p:nvPr/>
+        </p:nvSpPr>
+        <p:spPr>
+          <a:xfrm>
+            <a:off x="713232" y="1097280"/>
+            <a:ext cx="7717536" cy="3785616"/>
+          </a:xfrm>
+          <a:prstGeom prst="roundRect">
+            <a:avLst>
+              <a:gd name="adj" fmla="val 1932"/>
+            </a:avLst>
+          </a:prstGeom>
+          <a:solidFill>
+            <a:srgbClr val="FCFCFB"/>
+          </a:solidFill>
+          <a:ln/>
+        </p:spPr>
+      </p:sp>
       <p:pic>
         <p:nvPicPr>
-          <p:cNvPr id="3" name="chart weak classes" descr="Grouped bars of recognized time per exercise for final v1 and v2: lateral raise 5 to 64, bicep curl 65 to 81, tricep extension 60 to 72, dumbbell row 41 to 22">    </p:cNvPr>
+          <p:cNvPr id="4" name="chart weak classes" descr="Grouped bars of recognized time per exercise for final v1 and v2: lateral raise 5 to 64, bicep curl 65 to 81, tricep extension 60 to 72, dumbbell row 41 to 22">    </p:cNvPr>
           <p:cNvPicPr>
             <a:picLocks noChangeAspect="1"/>
           </p:cNvPicPr>
@@ -4444,7 +4516,7 @@
             <a:r>
               <a:rPr lang="en-US" sz="3200" b="1" dirty="0">
                 <a:solidFill>
-                  <a:schemeClr val="tx1"/>
+                  <a:schemeClr val="bg1"/>
                 </a:solidFill>
                 <a:latin typeface="Cambria" pitchFamily="34" charset="0"/>
                 <a:ea typeface="Cambria" pitchFamily="34" charset="-122"/>
@@ -4456,9 +4528,31 @@
           </a:p>
         </p:txBody>
       </p:sp>
+      <p:sp>
+        <p:nvSpPr>
+          <p:cNvPr id="3" name="chart card"/>
+          <p:cNvSpPr/>
+          <p:nvPr/>
+        </p:nvSpPr>
+        <p:spPr>
+          <a:xfrm>
+            <a:off x="438912" y="1097280"/>
+            <a:ext cx="8266176" cy="2084832"/>
+          </a:xfrm>
+          <a:prstGeom prst="roundRect">
+            <a:avLst>
+              <a:gd name="adj" fmla="val 3509"/>
+            </a:avLst>
+          </a:prstGeom>
+          <a:solidFill>
+            <a:srgbClr val="FCFCFB"/>
+          </a:solidFill>
+          <a:ln/>
+        </p:spPr>
+      </p:sp>
       <p:pic>
         <p:nvPicPr>
-          <p:cNvPr id="3" name="chart timeline" descr="Timeline of one unseen workout: hand-labeled exercise blocks on top, model prediction below">    </p:cNvPr>
+          <p:cNvPr id="4" name="chart timeline" descr="Timeline of one unseen workout: hand-labeled exercise blocks on top, model prediction below">    </p:cNvPr>
           <p:cNvPicPr>
             <a:picLocks noChangeAspect="1"/>
           </p:cNvPicPr>
@@ -4482,7 +4576,7 @@
       </p:pic>
       <p:sp>
         <p:nvSpPr>
-          <p:cNvPr id="4" name="right column"/>
+          <p:cNvPr id="5" name="right column"/>
           <p:cNvSpPr txBox="1"/>
           <p:nvPr/>
         </p:nvSpPr>
@@ -4510,7 +4604,7 @@
             <a:r>
               <a:rPr lang="en-US" sz="1800" b="1" dirty="0">
                 <a:solidFill>
-                  <a:schemeClr val="accent4"/>
+                  <a:srgbClr val="2FCB93"/>
                 </a:solidFill>
                 <a:latin typeface="Cambria" pitchFamily="34" charset="0"/>
                 <a:ea typeface="Cambria" pitchFamily="34" charset="-122"/>
@@ -4531,7 +4625,7 @@
             <a:r>
               <a:rPr lang="en-US" sz="1400" dirty="0">
                 <a:solidFill>
-                  <a:schemeClr val="tx2"/>
+                  <a:srgbClr val="C9CEDF"/>
                 </a:solidFill>
                 <a:latin typeface="Calibri" pitchFamily="34" charset="0"/>
                 <a:ea typeface="Calibri" pitchFamily="34" charset="-122"/>
@@ -4552,7 +4646,7 @@
             <a:r>
               <a:rPr lang="en-US" sz="1400" dirty="0">
                 <a:solidFill>
-                  <a:schemeClr val="tx2"/>
+                  <a:srgbClr val="C9CEDF"/>
                 </a:solidFill>
                 <a:latin typeface="Calibri" pitchFamily="34" charset="0"/>
                 <a:ea typeface="Calibri" pitchFamily="34" charset="-122"/>
@@ -4566,7 +4660,7 @@
       </p:sp>
       <p:sp>
         <p:nvSpPr>
-          <p:cNvPr id="5" name="wrong column"/>
+          <p:cNvPr id="6" name="wrong column"/>
           <p:cNvSpPr txBox="1"/>
           <p:nvPr/>
         </p:nvSpPr>
@@ -4594,7 +4688,7 @@
             <a:r>
               <a:rPr lang="en-US" sz="1800" b="1" dirty="0">
                 <a:solidFill>
-                  <a:schemeClr val="accent1"/>
+                  <a:srgbClr val="FF7A45"/>
                 </a:solidFill>
                 <a:latin typeface="Cambria" pitchFamily="34" charset="0"/>
                 <a:ea typeface="Cambria" pitchFamily="34" charset="-122"/>
@@ -4615,7 +4709,7 @@
             <a:r>
               <a:rPr lang="en-US" sz="1400" dirty="0">
                 <a:solidFill>
-                  <a:schemeClr val="tx2"/>
+                  <a:srgbClr val="C9CEDF"/>
                 </a:solidFill>
                 <a:latin typeface="Calibri" pitchFamily="34" charset="0"/>
                 <a:ea typeface="Calibri" pitchFamily="34" charset="-122"/>
@@ -4636,7 +4730,7 @@
             <a:r>
               <a:rPr lang="en-US" sz="1400" dirty="0">
                 <a:solidFill>
-                  <a:schemeClr val="tx2"/>
+                  <a:srgbClr val="C9CEDF"/>
                 </a:solidFill>
                 <a:latin typeface="Calibri" pitchFamily="34" charset="0"/>
                 <a:ea typeface="Calibri" pitchFamily="34" charset="-122"/>
@@ -4750,7 +4844,7 @@
             <a:r>
               <a:rPr lang="en-US" sz="3200" b="1" dirty="0">
                 <a:solidFill>
-                  <a:schemeClr val="tx1"/>
+                  <a:schemeClr val="bg1"/>
                 </a:solidFill>
                 <a:latin typeface="Cambria" pitchFamily="34" charset="0"/>
                 <a:ea typeface="Cambria" pitchFamily="34" charset="-122"/>
@@ -4777,7 +4871,7 @@
             <a:avLst/>
           </a:prstGeom>
           <a:solidFill>
-            <a:schemeClr val="accent1"/>
+            <a:srgbClr val="FF7A45"/>
           </a:solidFill>
           <a:ln/>
         </p:spPr>
@@ -4848,7 +4942,7 @@
             <a:r>
               <a:rPr lang="en-US" sz="1800" b="1" dirty="0">
                 <a:solidFill>
-                  <a:schemeClr val="tx1"/>
+                  <a:schemeClr val="bg1"/>
                 </a:solidFill>
                 <a:latin typeface="Cambria" pitchFamily="34" charset="0"/>
                 <a:ea typeface="Cambria" pitchFamily="34" charset="-122"/>
@@ -4887,7 +4981,7 @@
             <a:r>
               <a:rPr lang="en-US" sz="1400" dirty="0">
                 <a:solidFill>
-                  <a:schemeClr val="tx2"/>
+                  <a:srgbClr val="C9CEDF"/>
                 </a:solidFill>
                 <a:latin typeface="Calibri" pitchFamily="34" charset="0"/>
                 <a:ea typeface="Calibri" pitchFamily="34" charset="-122"/>
@@ -4914,7 +5008,7 @@
             <a:avLst/>
           </a:prstGeom>
           <a:solidFill>
-            <a:schemeClr val="accent2"/>
+            <a:srgbClr val="8F84F0"/>
           </a:solidFill>
           <a:ln/>
         </p:spPr>
@@ -4985,7 +5079,7 @@
             <a:r>
               <a:rPr lang="en-US" sz="1800" b="1" dirty="0">
                 <a:solidFill>
-                  <a:schemeClr val="tx1"/>
+                  <a:schemeClr val="bg1"/>
                 </a:solidFill>
                 <a:latin typeface="Cambria" pitchFamily="34" charset="0"/>
                 <a:ea typeface="Cambria" pitchFamily="34" charset="-122"/>
@@ -5024,7 +5118,7 @@
             <a:r>
               <a:rPr lang="en-US" sz="1400" dirty="0">
                 <a:solidFill>
-                  <a:schemeClr val="tx2"/>
+                  <a:srgbClr val="C9CEDF"/>
                 </a:solidFill>
                 <a:latin typeface="Calibri" pitchFamily="34" charset="0"/>
                 <a:ea typeface="Calibri" pitchFamily="34" charset="-122"/>
@@ -5051,7 +5145,7 @@
             <a:avLst/>
           </a:prstGeom>
           <a:solidFill>
-            <a:schemeClr val="accent3"/>
+            <a:srgbClr val="5B9BEB"/>
           </a:solidFill>
           <a:ln/>
         </p:spPr>
@@ -5122,7 +5216,7 @@
             <a:r>
               <a:rPr lang="en-US" sz="1800" b="1" dirty="0">
                 <a:solidFill>
-                  <a:schemeClr val="tx1"/>
+                  <a:schemeClr val="bg1"/>
                 </a:solidFill>
                 <a:latin typeface="Cambria" pitchFamily="34" charset="0"/>
                 <a:ea typeface="Cambria" pitchFamily="34" charset="-122"/>
@@ -5161,7 +5255,7 @@
             <a:r>
               <a:rPr lang="en-US" sz="1400" dirty="0">
                 <a:solidFill>
-                  <a:schemeClr val="tx2"/>
+                  <a:srgbClr val="C9CEDF"/>
                 </a:solidFill>
                 <a:latin typeface="Calibri" pitchFamily="34" charset="0"/>
                 <a:ea typeface="Calibri" pitchFamily="34" charset="-122"/>
@@ -5188,7 +5282,7 @@
             <a:avLst/>
           </a:prstGeom>
           <a:solidFill>
-            <a:schemeClr val="accent4"/>
+            <a:srgbClr val="2FCB93"/>
           </a:solidFill>
           <a:ln/>
         </p:spPr>
@@ -5259,7 +5353,7 @@
             <a:r>
               <a:rPr lang="en-US" sz="1800" b="1" dirty="0">
                 <a:solidFill>
-                  <a:schemeClr val="tx1"/>
+                  <a:schemeClr val="bg1"/>
                 </a:solidFill>
                 <a:latin typeface="Cambria" pitchFamily="34" charset="0"/>
                 <a:ea typeface="Cambria" pitchFamily="34" charset="-122"/>
@@ -5298,7 +5392,7 @@
             <a:r>
               <a:rPr lang="en-US" sz="1400" dirty="0">
                 <a:solidFill>
-                  <a:schemeClr val="tx2"/>
+                  <a:srgbClr val="C9CEDF"/>
                 </a:solidFill>
                 <a:latin typeface="Calibri" pitchFamily="34" charset="0"/>
                 <a:ea typeface="Calibri" pitchFamily="34" charset="-122"/>
@@ -5412,7 +5506,7 @@
             <a:r>
               <a:rPr lang="en-US" sz="3200" b="1" dirty="0">
                 <a:solidFill>
-                  <a:schemeClr val="tx1"/>
+                  <a:schemeClr val="bg1"/>
                 </a:solidFill>
                 <a:latin typeface="Cambria" pitchFamily="34" charset="0"/>
                 <a:ea typeface="Cambria" pitchFamily="34" charset="-122"/>
@@ -5455,13 +5549,13 @@
             <a:r>
               <a:rPr lang="en-US" sz="1600" dirty="0">
                 <a:solidFill>
-                  <a:schemeClr val="tx2"/>
+                  <a:srgbClr val="C9CEDF"/>
                 </a:solidFill>
                 <a:latin typeface="Calibri" pitchFamily="34" charset="0"/>
                 <a:ea typeface="Calibri" pitchFamily="34" charset="-122"/>
                 <a:cs typeface="Calibri" pitchFamily="34" charset="-120"/>
               </a:rPr>
-              <a:t>Runs on your own computer. One command starts it.</a:t>
+              <a:t>Runs on your own computer. One command starts it; long videos (up to 4 GB) are fine.</a:t>
             </a:r>
             <a:endParaRPr lang="en-US" sz="1600" dirty="0"/>
           </a:p>
@@ -5476,7 +5570,7 @@
             <a:r>
               <a:rPr lang="en-US" sz="1600" dirty="0">
                 <a:solidFill>
-                  <a:schemeClr val="tx2"/>
+                  <a:srgbClr val="C9CEDF"/>
                 </a:solidFill>
                 <a:latin typeface="Calibri" pitchFamily="34" charset="0"/>
                 <a:ea typeface="Calibri" pitchFamily="34" charset="-122"/>
@@ -5497,7 +5591,7 @@
             <a:r>
               <a:rPr lang="en-US" sz="1600" dirty="0">
                 <a:solidFill>
-                  <a:schemeClr val="tx2"/>
+                  <a:srgbClr val="C9CEDF"/>
                 </a:solidFill>
                 <a:latin typeface="Calibri" pitchFamily="34" charset="0"/>
                 <a:ea typeface="Calibri" pitchFamily="34" charset="-122"/>
@@ -5518,7 +5612,7 @@
             <a:r>
               <a:rPr lang="en-US" sz="1600" dirty="0">
                 <a:solidFill>
-                  <a:schemeClr val="tx2"/>
+                  <a:srgbClr val="C9CEDF"/>
                 </a:solidFill>
                 <a:latin typeface="Calibri" pitchFamily="34" charset="0"/>
                 <a:ea typeface="Calibri" pitchFamily="34" charset="-122"/>
@@ -5557,7 +5651,7 @@
             <a:r>
               <a:rPr lang="en-US" sz="5400" b="1" dirty="0">
                 <a:solidFill>
-                  <a:schemeClr val="accent2"/>
+                  <a:srgbClr val="8F84F0"/>
                 </a:solidFill>
                 <a:latin typeface="Cambria" pitchFamily="34" charset="0"/>
                 <a:ea typeface="Cambria" pitchFamily="34" charset="-122"/>
@@ -5596,7 +5690,7 @@
             <a:r>
               <a:rPr lang="en-US" sz="1600" dirty="0">
                 <a:solidFill>
-                  <a:schemeClr val="tx2"/>
+                  <a:srgbClr val="C9CEDF"/>
                 </a:solidFill>
                 <a:latin typeface="Calibri" pitchFamily="34" charset="0"/>
                 <a:ea typeface="Calibri" pitchFamily="34" charset="-122"/>
@@ -5635,7 +5729,7 @@
             <a:r>
               <a:rPr lang="en-US" sz="1400" dirty="0">
                 <a:solidFill>
-                  <a:schemeClr val="tx2"/>
+                  <a:srgbClr val="C9CEDF"/>
                 </a:solidFill>
                 <a:latin typeface="Calibri" pitchFamily="34" charset="0"/>
                 <a:ea typeface="Calibri" pitchFamily="34" charset="-122"/>

</xml_diff>